<commit_message>
Update slide 02 simple idea
</commit_message>
<xml_diff>
--- a/presentation/deck/yacoub-thesis-presentation.pptx
+++ b/presentation/deck/yacoub-thesis-presentation.pptx
@@ -2,13 +2,14 @@
 <file path=ppt/presentation.xml><?xml version="1.0" encoding="utf-8"?>
 <p:presentation xmlns:p="http://schemas.openxmlformats.org/presentationml/2006/main">
   <p:sldMasterIdLst>
-    <p:sldMasterId xmlns:r="http://schemas.openxmlformats.org/officeDocument/2006/relationships" id="2147483648" r:id="R846e1ea44b5a456b"/>
+    <p:sldMasterId xmlns:r="http://schemas.openxmlformats.org/officeDocument/2006/relationships" id="2147483648" r:id="Rbb7a9006f71e42a6"/>
   </p:sldMasterIdLst>
   <p:notesMasterIdLst>
-    <p:notesMasterId xmlns:r="http://schemas.openxmlformats.org/officeDocument/2006/relationships" r:id="Rcf2170ae0a934b43"/>
+    <p:notesMasterId xmlns:r="http://schemas.openxmlformats.org/officeDocument/2006/relationships" r:id="Re7245a7bed444dad"/>
   </p:notesMasterIdLst>
   <p:sldIdLst>
-    <p:sldId xmlns:r="http://schemas.openxmlformats.org/officeDocument/2006/relationships" id="256" r:id="R95ff69a448b34e89"/>
+    <p:sldId xmlns:r="http://schemas.openxmlformats.org/officeDocument/2006/relationships" id="256" r:id="Rb30cf6c837034064"/>
+    <p:sldId xmlns:r="http://schemas.openxmlformats.org/officeDocument/2006/relationships" id="257" r:id="R08bc0427b6fc446c"/>
   </p:sldIdLst>
   <p:sldSz cx="12192000" cy="6858000"/>
   <p:notesSz cx="6858000" cy="9144000"/>
@@ -487,6 +488,76 @@
 </p:notes>
 </file>
 
+<file path=ppt/notesSlides/notesSlide2.xml><?xml version="1.0" encoding="utf-8"?>
+<p:notes xmlns:p="http://schemas.openxmlformats.org/presentationml/2006/main">
+  <p:cSld>
+    <p:spTree>
+      <p:nvGrpSpPr>
+        <p:cNvPr id="1" name=""/>
+        <p:cNvGrpSpPr/>
+        <p:nvPr/>
+      </p:nvGrpSpPr>
+      <p:grpSpPr>
+        <a:xfrm xmlns:a="http://schemas.openxmlformats.org/drawingml/2006/main"/>
+      </p:grpSpPr>
+      <p:sp>
+        <p:nvSpPr>
+          <p:cNvPr id="2" name="Slide Image Placeholder 1"/>
+          <p:cNvSpPr>
+            <a:spLocks xmlns:a="http://schemas.openxmlformats.org/drawingml/2006/main" noGrp="1"/>
+          </p:cNvSpPr>
+          <p:nvPr>
+            <p:ph type="sldImg" idx="0"/>
+          </p:nvPr>
+        </p:nvSpPr>
+        <p:spPr/>
+      </p:sp>
+      <p:sp>
+        <p:nvSpPr>
+          <p:cNvPr id="3" name="Notes Placeholder 2"/>
+          <p:cNvSpPr>
+            <a:spLocks xmlns:a="http://schemas.openxmlformats.org/drawingml/2006/main" noGrp="1"/>
+          </p:cNvSpPr>
+          <p:nvPr>
+            <p:ph type="body" idx="1"/>
+          </p:nvPr>
+        </p:nvSpPr>
+        <p:spPr/>
+        <p:txBody>
+          <a:bodyPr xmlns:a="http://schemas.openxmlformats.org/drawingml/2006/main"/>
+          <a:lstStyle xmlns:a="http://schemas.openxmlformats.org/drawingml/2006/main"/>
+          <a:p xmlns:a="http://schemas.openxmlformats.org/drawingml/2006/main">
+            <a:r>
+              <a:t/>
+            </a:r>
+          </a:p>
+        </p:txBody>
+      </p:sp>
+      <p:sp>
+        <p:nvSpPr>
+          <p:cNvPr id="4" name="Slide Number Placeholder 3"/>
+          <p:cNvSpPr>
+            <a:spLocks xmlns:a="http://schemas.openxmlformats.org/drawingml/2006/main" noGrp="1"/>
+          </p:cNvSpPr>
+          <p:nvPr>
+            <p:ph type="sldNum" idx="5"/>
+          </p:nvPr>
+        </p:nvSpPr>
+        <p:spPr/>
+        <p:txBody>
+          <a:bodyPr xmlns:a="http://schemas.openxmlformats.org/drawingml/2006/main"/>
+          <a:lstStyle xmlns:a="http://schemas.openxmlformats.org/drawingml/2006/main"/>
+          <a:p xmlns:a="http://schemas.openxmlformats.org/drawingml/2006/main"/>
+        </p:txBody>
+      </p:sp>
+    </p:spTree>
+  </p:cSld>
+  <p:clrMapOvr>
+    <a:masterClrMapping xmlns:a="http://schemas.openxmlformats.org/drawingml/2006/main"/>
+  </p:clrMapOvr>
+</p:notes>
+</file>
+
 <file path=ppt/slideLayouts/slideLayout1.xml><?xml version="1.0" encoding="utf-8"?>
 <p:sldLayout xmlns:p="http://schemas.openxmlformats.org/presentationml/2006/main" type="title" preserve="1">
   <p:cSld name="Rubrikbild">
@@ -1630,7 +1701,7 @@
           <p:nvPr/>
         </p:nvPicPr>
         <p:blipFill>
-          <a:blip xmlns:r="http://schemas.openxmlformats.org/officeDocument/2006/relationships" xmlns:a="http://schemas.openxmlformats.org/drawingml/2006/main" r:embed="R40a85d06f06e4fcf"/>
+          <a:blip xmlns:r="http://schemas.openxmlformats.org/officeDocument/2006/relationships" xmlns:a="http://schemas.openxmlformats.org/drawingml/2006/main" r:embed="Re76e2b02b52d4ef6"/>
           <a:srcRect xmlns:a="http://schemas.openxmlformats.org/drawingml/2006/main" l="0" t="0" r="0" b="0"/>
           <a:stretch xmlns:a="http://schemas.openxmlformats.org/drawingml/2006/main">
             <a:fillRect l="0" t="0" r="0" b="0"/>
@@ -3485,7 +3556,7 @@
           <p:nvPr/>
         </p:nvPicPr>
         <p:blipFill>
-          <a:blip xmlns:r="http://schemas.openxmlformats.org/officeDocument/2006/relationships" xmlns:a="http://schemas.openxmlformats.org/drawingml/2006/main" r:embed="Refa3f2f66f364388"/>
+          <a:blip xmlns:r="http://schemas.openxmlformats.org/officeDocument/2006/relationships" xmlns:a="http://schemas.openxmlformats.org/drawingml/2006/main" r:embed="R7b083a74abef4aba"/>
           <a:srcRect xmlns:a="http://schemas.openxmlformats.org/drawingml/2006/main" l="0" t="0" r="0" b="0"/>
           <a:stretch xmlns:a="http://schemas.openxmlformats.org/drawingml/2006/main">
             <a:fillRect l="0" t="0" r="0" b="0"/>
@@ -3556,19 +3627,19 @@
   </p:cSld>
   <p:clrMap bg1="lt1" tx1="dk1" bg2="lt2" tx2="dk2" accent1="accent1" accent2="accent2" accent3="accent3" accent4="accent4" accent5="accent5" accent6="accent6" hlink="hlink" folHlink="folHlink"/>
   <p:sldLayoutIdLst>
-    <p:sldLayoutId xmlns:r="http://schemas.openxmlformats.org/officeDocument/2006/relationships" id="2147483649" r:id="Rd91d8cfde94043a1"/>
-    <p:sldLayoutId xmlns:r="http://schemas.openxmlformats.org/officeDocument/2006/relationships" id="2147483650" r:id="R420b388923114b23"/>
-    <p:sldLayoutId xmlns:r="http://schemas.openxmlformats.org/officeDocument/2006/relationships" id="2147483651" r:id="Refb33206611c42a5"/>
-    <p:sldLayoutId xmlns:r="http://schemas.openxmlformats.org/officeDocument/2006/relationships" id="2147483652" r:id="R8e63a7a955404c62"/>
-    <p:sldLayoutId xmlns:r="http://schemas.openxmlformats.org/officeDocument/2006/relationships" id="2147483653" r:id="Rc4c04228ff0e478a"/>
-    <p:sldLayoutId xmlns:r="http://schemas.openxmlformats.org/officeDocument/2006/relationships" id="2147483654" r:id="R7bfbd80f8c9f4b27"/>
-    <p:sldLayoutId xmlns:r="http://schemas.openxmlformats.org/officeDocument/2006/relationships" id="2147483655" r:id="R3bd6041b28534191"/>
-    <p:sldLayoutId xmlns:r="http://schemas.openxmlformats.org/officeDocument/2006/relationships" id="2147483656" r:id="Rc67035bffeb04cdc"/>
-    <p:sldLayoutId xmlns:r="http://schemas.openxmlformats.org/officeDocument/2006/relationships" id="2147483657" r:id="Rc76c3bf1810a4314"/>
-    <p:sldLayoutId xmlns:r="http://schemas.openxmlformats.org/officeDocument/2006/relationships" id="2147483658" r:id="R283c55e6c2704895"/>
-    <p:sldLayoutId xmlns:r="http://schemas.openxmlformats.org/officeDocument/2006/relationships" id="2147483659" r:id="R36e2290ba40c4f83"/>
-    <p:sldLayoutId xmlns:r="http://schemas.openxmlformats.org/officeDocument/2006/relationships" id="2147483660" r:id="R8391388745974d8f"/>
-    <p:sldLayoutId xmlns:r="http://schemas.openxmlformats.org/officeDocument/2006/relationships" id="2147483661" r:id="R6bafb1b972014f5a"/>
+    <p:sldLayoutId xmlns:r="http://schemas.openxmlformats.org/officeDocument/2006/relationships" id="2147483649" r:id="R13b2b715e17f4f45"/>
+    <p:sldLayoutId xmlns:r="http://schemas.openxmlformats.org/officeDocument/2006/relationships" id="2147483650" r:id="R792f3816134f492f"/>
+    <p:sldLayoutId xmlns:r="http://schemas.openxmlformats.org/officeDocument/2006/relationships" id="2147483651" r:id="Rad31a86ce441448f"/>
+    <p:sldLayoutId xmlns:r="http://schemas.openxmlformats.org/officeDocument/2006/relationships" id="2147483652" r:id="Rdb3103b4db414b39"/>
+    <p:sldLayoutId xmlns:r="http://schemas.openxmlformats.org/officeDocument/2006/relationships" id="2147483653" r:id="R89eda5b451a34f0a"/>
+    <p:sldLayoutId xmlns:r="http://schemas.openxmlformats.org/officeDocument/2006/relationships" id="2147483654" r:id="R5e1e4e948fe84a8f"/>
+    <p:sldLayoutId xmlns:r="http://schemas.openxmlformats.org/officeDocument/2006/relationships" id="2147483655" r:id="Raf933604f3e948fe"/>
+    <p:sldLayoutId xmlns:r="http://schemas.openxmlformats.org/officeDocument/2006/relationships" id="2147483656" r:id="R09beef1f5f0c4d3d"/>
+    <p:sldLayoutId xmlns:r="http://schemas.openxmlformats.org/officeDocument/2006/relationships" id="2147483657" r:id="Rc704a0af86454ce6"/>
+    <p:sldLayoutId xmlns:r="http://schemas.openxmlformats.org/officeDocument/2006/relationships" id="2147483658" r:id="R6a94353e4bad4fe0"/>
+    <p:sldLayoutId xmlns:r="http://schemas.openxmlformats.org/officeDocument/2006/relationships" id="2147483659" r:id="Rc1ed1cbed7fd46fb"/>
+    <p:sldLayoutId xmlns:r="http://schemas.openxmlformats.org/officeDocument/2006/relationships" id="2147483660" r:id="R6b492ff4ca844a29"/>
+    <p:sldLayoutId xmlns:r="http://schemas.openxmlformats.org/officeDocument/2006/relationships" id="2147483661" r:id="R7aece71b428b4857"/>
   </p:sldLayoutIdLst>
   <p:txStyles>
     <p:titleStyle>
@@ -4193,6 +4264,744 @@
 </p:sld>
 </file>
 
+<file path=ppt/slides/slide2.xml><?xml version="1.0" encoding="utf-8"?>
+<p:sld xmlns:p="http://schemas.openxmlformats.org/presentationml/2006/main">
+  <p:cSld>
+    <p:spTree>
+      <p:nvGrpSpPr>
+        <p:cNvPr id="1" name=""/>
+        <p:cNvGrpSpPr/>
+        <p:nvPr/>
+      </p:nvGrpSpPr>
+      <p:grpSpPr>
+        <a:xfrm xmlns:a="http://schemas.openxmlformats.org/drawingml/2006/main"/>
+      </p:grpSpPr>
+      <p:sp>
+        <p:nvSpPr>
+          <p:cNvPr id="1" name="text">
+            <a:extLst xmlns:a="http://schemas.openxmlformats.org/drawingml/2006/main">
+              <a:ext uri="{FF2B5EF4-FFF2-40B4-BE49-F238E27FC236}">
+                <a16:creationId xmlns:a16="http://schemas.microsoft.com/office/drawing/2014/main" id="{27BD5289-5D29-4341-9FBF-85F089E650AC}"/>
+              </a:ext>
+            </a:extLst>
+          </p:cNvPr>
+          <p:cNvSpPr>
+            <a:spLocks xmlns:a="http://schemas.openxmlformats.org/drawingml/2006/main" noGrp="1"/>
+          </p:cNvSpPr>
+          <p:nvPr/>
+        </p:nvSpPr>
+        <p:spPr>
+          <a:xfrm xmlns:a="http://schemas.openxmlformats.org/drawingml/2006/main">
+            <a:off x="781050" y="1485900"/>
+            <a:ext cx="7239000" cy="552450"/>
+          </a:xfrm>
+          <a:prstGeom xmlns:a="http://schemas.openxmlformats.org/drawingml/2006/main" prst="rect">
+            <a:avLst/>
+          </a:prstGeom>
+          <a:solidFill xmlns:a="http://schemas.openxmlformats.org/drawingml/2006/main">
+            <a:srgbClr val="000000">
+              <a:alpha val="0"/>
+            </a:srgbClr>
+          </a:solidFill>
+          <a:ln xmlns:a="http://schemas.openxmlformats.org/drawingml/2006/main" w="0">
+            <a:solidFill>
+              <a:srgbClr val="000000">
+                <a:alpha val="0"/>
+              </a:srgbClr>
+            </a:solidFill>
+            <a:prstDash val="solid"/>
+          </a:ln>
+        </p:spPr>
+        <p:txBody>
+          <a:bodyPr xmlns:a="http://schemas.openxmlformats.org/drawingml/2006/main" anchor="t"/>
+          <a:lstStyle xmlns:a="http://schemas.openxmlformats.org/drawingml/2006/main"/>
+          <a:p xmlns:a="http://schemas.openxmlformats.org/drawingml/2006/main">
+            <a:pPr algn="l">
+              <a:defRPr sz="3300" b="1">
+                <a:solidFill>
+                  <a:srgbClr val="0065BD"/>
+                </a:solidFill>
+                <a:latin typeface="Arial"/>
+                <a:ea typeface="Arial"/>
+                <a:cs typeface="Arial"/>
+              </a:defRPr>
+            </a:pPr>
+            <a:r>
+              <a:rPr sz="3300" b="1">
+                <a:solidFill>
+                  <a:srgbClr val="0065BD"/>
+                </a:solidFill>
+                <a:latin typeface="Arial"/>
+                <a:ea typeface="Arial"/>
+                <a:cs typeface="Arial"/>
+              </a:rPr>
+              <a:t>The simple idea</a:t>
+            </a:r>
+          </a:p>
+        </p:txBody>
+      </p:sp>
+      <p:sp>
+        <p:nvSpPr>
+          <p:cNvPr id="2" name="flow-box">
+            <a:extLst xmlns:a="http://schemas.openxmlformats.org/drawingml/2006/main">
+              <a:ext uri="{FF2B5EF4-FFF2-40B4-BE49-F238E27FC236}">
+                <a16:creationId xmlns:a16="http://schemas.microsoft.com/office/drawing/2014/main" id="{188A68CC-FC1E-40D0-B3EB-F74D5FA17083}"/>
+              </a:ext>
+            </a:extLst>
+          </p:cNvPr>
+          <p:cNvSpPr>
+            <a:spLocks xmlns:a="http://schemas.openxmlformats.org/drawingml/2006/main" noGrp="1"/>
+          </p:cNvSpPr>
+          <p:nvPr/>
+        </p:nvSpPr>
+        <p:spPr>
+          <a:xfrm xmlns:a="http://schemas.openxmlformats.org/drawingml/2006/main">
+            <a:off x="781050" y="2714625"/>
+            <a:ext cx="2095500" cy="1123950"/>
+          </a:xfrm>
+          <a:prstGeom xmlns:a="http://schemas.openxmlformats.org/drawingml/2006/main" prst="rect">
+            <a:avLst/>
+          </a:prstGeom>
+          <a:solidFill xmlns:a="http://schemas.openxmlformats.org/drawingml/2006/main">
+            <a:srgbClr val="F7FAFC"/>
+          </a:solidFill>
+          <a:ln xmlns:a="http://schemas.openxmlformats.org/drawingml/2006/main" w="14288">
+            <a:solidFill>
+              <a:srgbClr val="B8C7D9"/>
+            </a:solidFill>
+            <a:prstDash val="solid"/>
+          </a:ln>
+        </p:spPr>
+        <p:txBody>
+          <a:bodyPr xmlns:a="http://schemas.openxmlformats.org/drawingml/2006/main" lIns="133350" tIns="114300" rIns="133350" bIns="114300" anchor="ctr"/>
+          <a:lstStyle xmlns:a="http://schemas.openxmlformats.org/drawingml/2006/main"/>
+          <a:p xmlns:a="http://schemas.openxmlformats.org/drawingml/2006/main">
+            <a:pPr algn="ctr">
+              <a:defRPr sz="1800" b="1">
+                <a:solidFill>
+                  <a:srgbClr val="111111"/>
+                </a:solidFill>
+                <a:latin typeface="Arial"/>
+                <a:ea typeface="Arial"/>
+                <a:cs typeface="Arial"/>
+              </a:defRPr>
+            </a:pPr>
+            <a:r>
+              <a:rPr sz="1800" b="1">
+                <a:solidFill>
+                  <a:srgbClr val="111111"/>
+                </a:solidFill>
+                <a:latin typeface="Arial"/>
+                <a:ea typeface="Arial"/>
+                <a:cs typeface="Arial"/>
+              </a:rPr>
+              <a:t>Temperature</a:t>
+            </a:r>
+          </a:p>
+          <a:p xmlns:a="http://schemas.openxmlformats.org/drawingml/2006/main">
+            <a:pPr algn="ctr">
+              <a:defRPr sz="1800" b="1">
+                <a:solidFill>
+                  <a:srgbClr val="111111"/>
+                </a:solidFill>
+                <a:latin typeface="Arial"/>
+                <a:ea typeface="Arial"/>
+                <a:cs typeface="Arial"/>
+              </a:defRPr>
+            </a:pPr>
+            <a:r>
+              <a:rPr sz="1800" b="1">
+                <a:solidFill>
+                  <a:srgbClr val="111111"/>
+                </a:solidFill>
+                <a:latin typeface="Arial"/>
+                <a:ea typeface="Arial"/>
+                <a:cs typeface="Arial"/>
+              </a:rPr>
+              <a:t>input</a:t>
+            </a:r>
+          </a:p>
+        </p:txBody>
+      </p:sp>
+      <p:sp>
+        <p:nvSpPr>
+          <p:cNvPr id="3" name="flow-box">
+            <a:extLst xmlns:a="http://schemas.openxmlformats.org/drawingml/2006/main">
+              <a:ext uri="{FF2B5EF4-FFF2-40B4-BE49-F238E27FC236}">
+                <a16:creationId xmlns:a16="http://schemas.microsoft.com/office/drawing/2014/main" id="{BAC9A467-7B17-431C-9737-A768342EC2B3}"/>
+              </a:ext>
+            </a:extLst>
+          </p:cNvPr>
+          <p:cNvSpPr>
+            <a:spLocks xmlns:a="http://schemas.openxmlformats.org/drawingml/2006/main" noGrp="1"/>
+          </p:cNvSpPr>
+          <p:nvPr/>
+        </p:nvSpPr>
+        <p:spPr>
+          <a:xfrm xmlns:a="http://schemas.openxmlformats.org/drawingml/2006/main">
+            <a:off x="3486150" y="2714625"/>
+            <a:ext cx="2095500" cy="1123950"/>
+          </a:xfrm>
+          <a:prstGeom xmlns:a="http://schemas.openxmlformats.org/drawingml/2006/main" prst="rect">
+            <a:avLst/>
+          </a:prstGeom>
+          <a:solidFill xmlns:a="http://schemas.openxmlformats.org/drawingml/2006/main">
+            <a:srgbClr val="F7FAFC"/>
+          </a:solidFill>
+          <a:ln xmlns:a="http://schemas.openxmlformats.org/drawingml/2006/main" w="14288">
+            <a:solidFill>
+              <a:srgbClr val="B8C7D9"/>
+            </a:solidFill>
+            <a:prstDash val="solid"/>
+          </a:ln>
+        </p:spPr>
+        <p:txBody>
+          <a:bodyPr xmlns:a="http://schemas.openxmlformats.org/drawingml/2006/main" lIns="133350" tIns="114300" rIns="133350" bIns="114300" anchor="ctr"/>
+          <a:lstStyle xmlns:a="http://schemas.openxmlformats.org/drawingml/2006/main"/>
+          <a:p xmlns:a="http://schemas.openxmlformats.org/drawingml/2006/main">
+            <a:pPr algn="ctr">
+              <a:defRPr sz="1800" b="1">
+                <a:solidFill>
+                  <a:srgbClr val="111111"/>
+                </a:solidFill>
+                <a:latin typeface="Arial"/>
+                <a:ea typeface="Arial"/>
+                <a:cs typeface="Arial"/>
+              </a:defRPr>
+            </a:pPr>
+            <a:r>
+              <a:rPr sz="1800" b="1">
+                <a:solidFill>
+                  <a:srgbClr val="111111"/>
+                </a:solidFill>
+                <a:latin typeface="Arial"/>
+                <a:ea typeface="Arial"/>
+                <a:cs typeface="Arial"/>
+              </a:rPr>
+              <a:t>n8n</a:t>
+            </a:r>
+          </a:p>
+          <a:p xmlns:a="http://schemas.openxmlformats.org/drawingml/2006/main">
+            <a:pPr algn="ctr">
+              <a:defRPr sz="1800" b="1">
+                <a:solidFill>
+                  <a:srgbClr val="111111"/>
+                </a:solidFill>
+                <a:latin typeface="Arial"/>
+                <a:ea typeface="Arial"/>
+                <a:cs typeface="Arial"/>
+              </a:defRPr>
+            </a:pPr>
+            <a:r>
+              <a:rPr sz="1800" b="1">
+                <a:solidFill>
+                  <a:srgbClr val="111111"/>
+                </a:solidFill>
+                <a:latin typeface="Arial"/>
+                <a:ea typeface="Arial"/>
+                <a:cs typeface="Arial"/>
+              </a:rPr>
+              <a:t>decision</a:t>
+            </a:r>
+          </a:p>
+        </p:txBody>
+      </p:sp>
+      <p:sp>
+        <p:nvSpPr>
+          <p:cNvPr id="4" name="flow-box">
+            <a:extLst xmlns:a="http://schemas.openxmlformats.org/drawingml/2006/main">
+              <a:ext uri="{FF2B5EF4-FFF2-40B4-BE49-F238E27FC236}">
+                <a16:creationId xmlns:a16="http://schemas.microsoft.com/office/drawing/2014/main" id="{8663E051-8E05-47AB-A854-539BC5A9DD3C}"/>
+              </a:ext>
+            </a:extLst>
+          </p:cNvPr>
+          <p:cNvSpPr>
+            <a:spLocks xmlns:a="http://schemas.openxmlformats.org/drawingml/2006/main" noGrp="1"/>
+          </p:cNvSpPr>
+          <p:nvPr/>
+        </p:nvSpPr>
+        <p:spPr>
+          <a:xfrm xmlns:a="http://schemas.openxmlformats.org/drawingml/2006/main">
+            <a:off x="6191250" y="2714625"/>
+            <a:ext cx="2095500" cy="1123950"/>
+          </a:xfrm>
+          <a:prstGeom xmlns:a="http://schemas.openxmlformats.org/drawingml/2006/main" prst="rect">
+            <a:avLst/>
+          </a:prstGeom>
+          <a:solidFill xmlns:a="http://schemas.openxmlformats.org/drawingml/2006/main">
+            <a:srgbClr val="F7FAFC"/>
+          </a:solidFill>
+          <a:ln xmlns:a="http://schemas.openxmlformats.org/drawingml/2006/main" w="14288">
+            <a:solidFill>
+              <a:srgbClr val="B8C7D9"/>
+            </a:solidFill>
+            <a:prstDash val="solid"/>
+          </a:ln>
+        </p:spPr>
+        <p:txBody>
+          <a:bodyPr xmlns:a="http://schemas.openxmlformats.org/drawingml/2006/main" lIns="133350" tIns="114300" rIns="133350" bIns="114300" anchor="ctr"/>
+          <a:lstStyle xmlns:a="http://schemas.openxmlformats.org/drawingml/2006/main"/>
+          <a:p xmlns:a="http://schemas.openxmlformats.org/drawingml/2006/main">
+            <a:pPr algn="ctr">
+              <a:defRPr sz="1800" b="1">
+                <a:solidFill>
+                  <a:srgbClr val="111111"/>
+                </a:solidFill>
+                <a:latin typeface="Arial"/>
+                <a:ea typeface="Arial"/>
+                <a:cs typeface="Arial"/>
+              </a:defRPr>
+            </a:pPr>
+            <a:r>
+              <a:rPr sz="1800" b="1">
+                <a:solidFill>
+                  <a:srgbClr val="111111"/>
+                </a:solidFill>
+                <a:latin typeface="Arial"/>
+                <a:ea typeface="Arial"/>
+                <a:cs typeface="Arial"/>
+              </a:rPr>
+              <a:t>Python</a:t>
+            </a:r>
+          </a:p>
+          <a:p xmlns:a="http://schemas.openxmlformats.org/drawingml/2006/main">
+            <a:pPr algn="ctr">
+              <a:defRPr sz="1800" b="1">
+                <a:solidFill>
+                  <a:srgbClr val="111111"/>
+                </a:solidFill>
+                <a:latin typeface="Arial"/>
+                <a:ea typeface="Arial"/>
+                <a:cs typeface="Arial"/>
+              </a:defRPr>
+            </a:pPr>
+            <a:r>
+              <a:rPr sz="1800" b="1">
+                <a:solidFill>
+                  <a:srgbClr val="111111"/>
+                </a:solidFill>
+                <a:latin typeface="Arial"/>
+                <a:ea typeface="Arial"/>
+                <a:cs typeface="Arial"/>
+              </a:rPr>
+              <a:t>middleware</a:t>
+            </a:r>
+          </a:p>
+        </p:txBody>
+      </p:sp>
+      <p:sp>
+        <p:nvSpPr>
+          <p:cNvPr id="5" name="flow-box">
+            <a:extLst xmlns:a="http://schemas.openxmlformats.org/drawingml/2006/main">
+              <a:ext uri="{FF2B5EF4-FFF2-40B4-BE49-F238E27FC236}">
+                <a16:creationId xmlns:a16="http://schemas.microsoft.com/office/drawing/2014/main" id="{6ABAC10C-4766-41CF-A039-66639204ABF8}"/>
+              </a:ext>
+            </a:extLst>
+          </p:cNvPr>
+          <p:cNvSpPr>
+            <a:spLocks xmlns:a="http://schemas.openxmlformats.org/drawingml/2006/main" noGrp="1"/>
+          </p:cNvSpPr>
+          <p:nvPr/>
+        </p:nvSpPr>
+        <p:spPr>
+          <a:xfrm xmlns:a="http://schemas.openxmlformats.org/drawingml/2006/main">
+            <a:off x="8896350" y="2714625"/>
+            <a:ext cx="2095500" cy="1123950"/>
+          </a:xfrm>
+          <a:prstGeom xmlns:a="http://schemas.openxmlformats.org/drawingml/2006/main" prst="rect">
+            <a:avLst/>
+          </a:prstGeom>
+          <a:solidFill xmlns:a="http://schemas.openxmlformats.org/drawingml/2006/main">
+            <a:srgbClr val="F7FAFC"/>
+          </a:solidFill>
+          <a:ln xmlns:a="http://schemas.openxmlformats.org/drawingml/2006/main" w="14288">
+            <a:solidFill>
+              <a:srgbClr val="B8C7D9"/>
+            </a:solidFill>
+            <a:prstDash val="solid"/>
+          </a:ln>
+        </p:spPr>
+        <p:txBody>
+          <a:bodyPr xmlns:a="http://schemas.openxmlformats.org/drawingml/2006/main" lIns="133350" tIns="114300" rIns="133350" bIns="114300" anchor="ctr"/>
+          <a:lstStyle xmlns:a="http://schemas.openxmlformats.org/drawingml/2006/main"/>
+          <a:p xmlns:a="http://schemas.openxmlformats.org/drawingml/2006/main">
+            <a:pPr algn="ctr">
+              <a:defRPr sz="1800" b="1">
+                <a:solidFill>
+                  <a:srgbClr val="111111"/>
+                </a:solidFill>
+                <a:latin typeface="Arial"/>
+                <a:ea typeface="Arial"/>
+                <a:cs typeface="Arial"/>
+              </a:defRPr>
+            </a:pPr>
+            <a:r>
+              <a:rPr sz="1800" b="1">
+                <a:solidFill>
+                  <a:srgbClr val="111111"/>
+                </a:solidFill>
+                <a:latin typeface="Arial"/>
+                <a:ea typeface="Arial"/>
+                <a:cs typeface="Arial"/>
+              </a:rPr>
+              <a:t>Simulated fan</a:t>
+            </a:r>
+          </a:p>
+          <a:p xmlns:a="http://schemas.openxmlformats.org/drawingml/2006/main">
+            <a:pPr algn="ctr">
+              <a:defRPr sz="1800" b="1">
+                <a:solidFill>
+                  <a:srgbClr val="111111"/>
+                </a:solidFill>
+                <a:latin typeface="Arial"/>
+                <a:ea typeface="Arial"/>
+                <a:cs typeface="Arial"/>
+              </a:defRPr>
+            </a:pPr>
+            <a:r>
+              <a:rPr sz="1800" b="1">
+                <a:solidFill>
+                  <a:srgbClr val="111111"/>
+                </a:solidFill>
+                <a:latin typeface="Arial"/>
+                <a:ea typeface="Arial"/>
+                <a:cs typeface="Arial"/>
+              </a:rPr>
+              <a:t>action</a:t>
+            </a:r>
+          </a:p>
+        </p:txBody>
+      </p:sp>
+      <p:sp>
+        <p:nvSpPr>
+          <p:cNvPr id="6" name="text">
+            <a:extLst xmlns:a="http://schemas.openxmlformats.org/drawingml/2006/main">
+              <a:ext uri="{FF2B5EF4-FFF2-40B4-BE49-F238E27FC236}">
+                <a16:creationId xmlns:a16="http://schemas.microsoft.com/office/drawing/2014/main" id="{C0C79110-923A-48FC-AD5B-6BA7E1A09520}"/>
+              </a:ext>
+            </a:extLst>
+          </p:cNvPr>
+          <p:cNvSpPr>
+            <a:spLocks xmlns:a="http://schemas.openxmlformats.org/drawingml/2006/main" noGrp="1"/>
+          </p:cNvSpPr>
+          <p:nvPr/>
+        </p:nvSpPr>
+        <p:spPr>
+          <a:xfrm xmlns:a="http://schemas.openxmlformats.org/drawingml/2006/main">
+            <a:off x="3019425" y="3019425"/>
+            <a:ext cx="552450" cy="514350"/>
+          </a:xfrm>
+          <a:prstGeom xmlns:a="http://schemas.openxmlformats.org/drawingml/2006/main" prst="rect">
+            <a:avLst/>
+          </a:prstGeom>
+          <a:solidFill xmlns:a="http://schemas.openxmlformats.org/drawingml/2006/main">
+            <a:srgbClr val="000000">
+              <a:alpha val="0"/>
+            </a:srgbClr>
+          </a:solidFill>
+          <a:ln xmlns:a="http://schemas.openxmlformats.org/drawingml/2006/main" w="0">
+            <a:solidFill>
+              <a:srgbClr val="000000">
+                <a:alpha val="0"/>
+              </a:srgbClr>
+            </a:solidFill>
+            <a:prstDash val="solid"/>
+          </a:ln>
+        </p:spPr>
+        <p:txBody>
+          <a:bodyPr xmlns:a="http://schemas.openxmlformats.org/drawingml/2006/main" anchor="t"/>
+          <a:lstStyle xmlns:a="http://schemas.openxmlformats.org/drawingml/2006/main"/>
+          <a:p xmlns:a="http://schemas.openxmlformats.org/drawingml/2006/main">
+            <a:pPr algn="ctr">
+              <a:defRPr sz="3000" b="1">
+                <a:solidFill>
+                  <a:srgbClr val="0065BD"/>
+                </a:solidFill>
+                <a:latin typeface="Arial"/>
+                <a:ea typeface="Arial"/>
+                <a:cs typeface="Arial"/>
+              </a:defRPr>
+            </a:pPr>
+            <a:r>
+              <a:rPr sz="3000" b="1">
+                <a:solidFill>
+                  <a:srgbClr val="0065BD"/>
+                </a:solidFill>
+                <a:latin typeface="Arial"/>
+                <a:ea typeface="Arial"/>
+                <a:cs typeface="Arial"/>
+              </a:rPr>
+              <a:t>→</a:t>
+            </a:r>
+          </a:p>
+        </p:txBody>
+      </p:sp>
+      <p:sp>
+        <p:nvSpPr>
+          <p:cNvPr id="7" name="text">
+            <a:extLst xmlns:a="http://schemas.openxmlformats.org/drawingml/2006/main">
+              <a:ext uri="{FF2B5EF4-FFF2-40B4-BE49-F238E27FC236}">
+                <a16:creationId xmlns:a16="http://schemas.microsoft.com/office/drawing/2014/main" id="{DDA7668F-6B98-4291-8C0F-E2DE96FA45E9}"/>
+              </a:ext>
+            </a:extLst>
+          </p:cNvPr>
+          <p:cNvSpPr>
+            <a:spLocks xmlns:a="http://schemas.openxmlformats.org/drawingml/2006/main" noGrp="1"/>
+          </p:cNvSpPr>
+          <p:nvPr/>
+        </p:nvSpPr>
+        <p:spPr>
+          <a:xfrm xmlns:a="http://schemas.openxmlformats.org/drawingml/2006/main">
+            <a:off x="5724525" y="3019425"/>
+            <a:ext cx="552450" cy="514350"/>
+          </a:xfrm>
+          <a:prstGeom xmlns:a="http://schemas.openxmlformats.org/drawingml/2006/main" prst="rect">
+            <a:avLst/>
+          </a:prstGeom>
+          <a:solidFill xmlns:a="http://schemas.openxmlformats.org/drawingml/2006/main">
+            <a:srgbClr val="000000">
+              <a:alpha val="0"/>
+            </a:srgbClr>
+          </a:solidFill>
+          <a:ln xmlns:a="http://schemas.openxmlformats.org/drawingml/2006/main" w="0">
+            <a:solidFill>
+              <a:srgbClr val="000000">
+                <a:alpha val="0"/>
+              </a:srgbClr>
+            </a:solidFill>
+            <a:prstDash val="solid"/>
+          </a:ln>
+        </p:spPr>
+        <p:txBody>
+          <a:bodyPr xmlns:a="http://schemas.openxmlformats.org/drawingml/2006/main" anchor="t"/>
+          <a:lstStyle xmlns:a="http://schemas.openxmlformats.org/drawingml/2006/main"/>
+          <a:p xmlns:a="http://schemas.openxmlformats.org/drawingml/2006/main">
+            <a:pPr algn="ctr">
+              <a:defRPr sz="3000" b="1">
+                <a:solidFill>
+                  <a:srgbClr val="0065BD"/>
+                </a:solidFill>
+                <a:latin typeface="Arial"/>
+                <a:ea typeface="Arial"/>
+                <a:cs typeface="Arial"/>
+              </a:defRPr>
+            </a:pPr>
+            <a:r>
+              <a:rPr sz="3000" b="1">
+                <a:solidFill>
+                  <a:srgbClr val="0065BD"/>
+                </a:solidFill>
+                <a:latin typeface="Arial"/>
+                <a:ea typeface="Arial"/>
+                <a:cs typeface="Arial"/>
+              </a:rPr>
+              <a:t>→</a:t>
+            </a:r>
+          </a:p>
+        </p:txBody>
+      </p:sp>
+      <p:sp>
+        <p:nvSpPr>
+          <p:cNvPr id="8" name="text">
+            <a:extLst xmlns:a="http://schemas.openxmlformats.org/drawingml/2006/main">
+              <a:ext uri="{FF2B5EF4-FFF2-40B4-BE49-F238E27FC236}">
+                <a16:creationId xmlns:a16="http://schemas.microsoft.com/office/drawing/2014/main" id="{C0059DEF-ACE4-44B1-8767-5FF9E8399CDF}"/>
+              </a:ext>
+            </a:extLst>
+          </p:cNvPr>
+          <p:cNvSpPr>
+            <a:spLocks xmlns:a="http://schemas.openxmlformats.org/drawingml/2006/main" noGrp="1"/>
+          </p:cNvSpPr>
+          <p:nvPr/>
+        </p:nvSpPr>
+        <p:spPr>
+          <a:xfrm xmlns:a="http://schemas.openxmlformats.org/drawingml/2006/main">
+            <a:off x="8429625" y="3019425"/>
+            <a:ext cx="552450" cy="514350"/>
+          </a:xfrm>
+          <a:prstGeom xmlns:a="http://schemas.openxmlformats.org/drawingml/2006/main" prst="rect">
+            <a:avLst/>
+          </a:prstGeom>
+          <a:solidFill xmlns:a="http://schemas.openxmlformats.org/drawingml/2006/main">
+            <a:srgbClr val="000000">
+              <a:alpha val="0"/>
+            </a:srgbClr>
+          </a:solidFill>
+          <a:ln xmlns:a="http://schemas.openxmlformats.org/drawingml/2006/main" w="0">
+            <a:solidFill>
+              <a:srgbClr val="000000">
+                <a:alpha val="0"/>
+              </a:srgbClr>
+            </a:solidFill>
+            <a:prstDash val="solid"/>
+          </a:ln>
+        </p:spPr>
+        <p:txBody>
+          <a:bodyPr xmlns:a="http://schemas.openxmlformats.org/drawingml/2006/main" anchor="t"/>
+          <a:lstStyle xmlns:a="http://schemas.openxmlformats.org/drawingml/2006/main"/>
+          <a:p xmlns:a="http://schemas.openxmlformats.org/drawingml/2006/main">
+            <a:pPr algn="ctr">
+              <a:defRPr sz="3000" b="1">
+                <a:solidFill>
+                  <a:srgbClr val="0065BD"/>
+                </a:solidFill>
+                <a:latin typeface="Arial"/>
+                <a:ea typeface="Arial"/>
+                <a:cs typeface="Arial"/>
+              </a:defRPr>
+            </a:pPr>
+            <a:r>
+              <a:rPr sz="3000" b="1">
+                <a:solidFill>
+                  <a:srgbClr val="0065BD"/>
+                </a:solidFill>
+                <a:latin typeface="Arial"/>
+                <a:ea typeface="Arial"/>
+                <a:cs typeface="Arial"/>
+              </a:rPr>
+              <a:t>→</a:t>
+            </a:r>
+          </a:p>
+        </p:txBody>
+      </p:sp>
+      <p:sp>
+        <p:nvSpPr>
+          <p:cNvPr id="9" name="text">
+            <a:extLst xmlns:a="http://schemas.openxmlformats.org/drawingml/2006/main">
+              <a:ext uri="{FF2B5EF4-FFF2-40B4-BE49-F238E27FC236}">
+                <a16:creationId xmlns:a16="http://schemas.microsoft.com/office/drawing/2014/main" id="{B4E1E3AC-875D-454B-957B-A87F37E0D30D}"/>
+              </a:ext>
+            </a:extLst>
+          </p:cNvPr>
+          <p:cNvSpPr>
+            <a:spLocks xmlns:a="http://schemas.openxmlformats.org/drawingml/2006/main" noGrp="1"/>
+          </p:cNvSpPr>
+          <p:nvPr/>
+        </p:nvSpPr>
+        <p:spPr>
+          <a:xfrm xmlns:a="http://schemas.openxmlformats.org/drawingml/2006/main">
+            <a:off x="8896350" y="3971925"/>
+            <a:ext cx="2095500" cy="266700"/>
+          </a:xfrm>
+          <a:prstGeom xmlns:a="http://schemas.openxmlformats.org/drawingml/2006/main" prst="rect">
+            <a:avLst/>
+          </a:prstGeom>
+          <a:solidFill xmlns:a="http://schemas.openxmlformats.org/drawingml/2006/main">
+            <a:srgbClr val="000000">
+              <a:alpha val="0"/>
+            </a:srgbClr>
+          </a:solidFill>
+          <a:ln xmlns:a="http://schemas.openxmlformats.org/drawingml/2006/main" w="0">
+            <a:solidFill>
+              <a:srgbClr val="000000">
+                <a:alpha val="0"/>
+              </a:srgbClr>
+            </a:solidFill>
+            <a:prstDash val="solid"/>
+          </a:ln>
+        </p:spPr>
+        <p:txBody>
+          <a:bodyPr xmlns:a="http://schemas.openxmlformats.org/drawingml/2006/main" anchor="t"/>
+          <a:lstStyle xmlns:a="http://schemas.openxmlformats.org/drawingml/2006/main"/>
+          <a:p xmlns:a="http://schemas.openxmlformats.org/drawingml/2006/main">
+            <a:pPr algn="ctr">
+              <a:defRPr sz="1500" b="1">
+                <a:solidFill>
+                  <a:srgbClr val="0065BD"/>
+                </a:solidFill>
+                <a:latin typeface="Arial"/>
+                <a:ea typeface="Arial"/>
+                <a:cs typeface="Arial"/>
+              </a:defRPr>
+            </a:pPr>
+            <a:r>
+              <a:rPr sz="1500" b="1">
+                <a:solidFill>
+                  <a:srgbClr val="0065BD"/>
+                </a:solidFill>
+                <a:latin typeface="Arial"/>
+                <a:ea typeface="Arial"/>
+                <a:cs typeface="Arial"/>
+              </a:rPr>
+              <a:t>fan_on / fan_off</a:t>
+            </a:r>
+          </a:p>
+        </p:txBody>
+      </p:sp>
+      <p:sp>
+        <p:nvSpPr>
+          <p:cNvPr id="10" name="text">
+            <a:extLst xmlns:a="http://schemas.openxmlformats.org/drawingml/2006/main">
+              <a:ext uri="{FF2B5EF4-FFF2-40B4-BE49-F238E27FC236}">
+                <a16:creationId xmlns:a16="http://schemas.microsoft.com/office/drawing/2014/main" id="{0E4B88B1-9C48-4FD8-A805-DAFA42208095}"/>
+              </a:ext>
+            </a:extLst>
+          </p:cNvPr>
+          <p:cNvSpPr>
+            <a:spLocks xmlns:a="http://schemas.openxmlformats.org/drawingml/2006/main" noGrp="1"/>
+          </p:cNvSpPr>
+          <p:nvPr/>
+        </p:nvSpPr>
+        <p:spPr>
+          <a:xfrm xmlns:a="http://schemas.openxmlformats.org/drawingml/2006/main">
+            <a:off x="781050" y="5286375"/>
+            <a:ext cx="10572750" cy="495300"/>
+          </a:xfrm>
+          <a:prstGeom xmlns:a="http://schemas.openxmlformats.org/drawingml/2006/main" prst="rect">
+            <a:avLst/>
+          </a:prstGeom>
+          <a:solidFill xmlns:a="http://schemas.openxmlformats.org/drawingml/2006/main">
+            <a:srgbClr val="000000">
+              <a:alpha val="0"/>
+            </a:srgbClr>
+          </a:solidFill>
+          <a:ln xmlns:a="http://schemas.openxmlformats.org/drawingml/2006/main" w="0">
+            <a:solidFill>
+              <a:srgbClr val="000000">
+                <a:alpha val="0"/>
+              </a:srgbClr>
+            </a:solidFill>
+            <a:prstDash val="solid"/>
+          </a:ln>
+        </p:spPr>
+        <p:txBody>
+          <a:bodyPr xmlns:a="http://schemas.openxmlformats.org/drawingml/2006/main" anchor="ctr"/>
+          <a:lstStyle xmlns:a="http://schemas.openxmlformats.org/drawingml/2006/main"/>
+          <a:p xmlns:a="http://schemas.openxmlformats.org/drawingml/2006/main">
+            <a:pPr algn="ctr">
+              <a:defRPr sz="2100" b="1">
+                <a:solidFill>
+                  <a:srgbClr val="111111"/>
+                </a:solidFill>
+                <a:latin typeface="Arial"/>
+                <a:ea typeface="Arial"/>
+                <a:cs typeface="Arial"/>
+              </a:defRPr>
+            </a:pPr>
+            <a:r>
+              <a:rPr sz="2100" b="1">
+                <a:solidFill>
+                  <a:srgbClr val="111111"/>
+                </a:solidFill>
+                <a:latin typeface="Arial"/>
+                <a:ea typeface="Arial"/>
+                <a:cs typeface="Arial"/>
+              </a:rPr>
+              <a:t>The fan is the test case. The architecture around the action is the thesis.</a:t>
+            </a:r>
+          </a:p>
+        </p:txBody>
+      </p:sp>
+    </p:spTree>
+    <p:extLst>
+      <p:ext uri="{BB962C8B-B14F-4D97-AF65-F5344CB8AC3E}">
+        <p14:creationId xmlns:p14="http://schemas.microsoft.com/office/powerpoint/2010/main" val="2166300922"/>
+      </p:ext>
+    </p:extLst>
+  </p:cSld>
+</p:sld>
+</file>
+
 <file path=ppt/theme/theme1.xml><?xml version="1.0" encoding="utf-8"?>
 <a:theme xmlns:a="http://schemas.openxmlformats.org/drawingml/2006/main" name="Office-tema">
   <a:themeElements>

</xml_diff>